<commit_message>
feat: add manual screenshots, proper references, references slide
- 8 paper figures from manual screenshots
- Figure captions now cite Source: Author et al., Venue, Figure N
- Added References slide (Splitwise, DistServe, Sarathi, vLLM, FlexGen)
- 33 slides total
- Regenerated all PDFs
</commit_message>
<xml_diff>
--- a/presentation/Phase_Disaggregation_LLM_Inference.pptx
+++ b/presentation/Phase_Disaggregation_LLM_Inference.pptx
@@ -37,6 +37,7 @@
     <p:sldId id="285" r:id="rId36"/>
     <p:sldId id="286" r:id="rId37"/>
     <p:sldId id="287" r:id="rId38"/>
+    <p:sldId id="288" r:id="rId39"/>
   </p:sldIdLst>
   <p:sldSz cx="12191695" cy="6858000" type="screen4x3"/>
   <p:notesSz cx="6858000" cy="9144000"/>
@@ -3389,7 +3390,7 @@
         <p:spPr>
           <a:xfrm>
             <a:off x="1737360" y="1097280"/>
-            <a:ext cx="8686800" cy="4885215"/>
+            <a:ext cx="8686800" cy="3926753"/>
           </a:xfrm>
           <a:prstGeom prst="rect">
             <a:avLst/>
@@ -3404,7 +3405,7 @@
         </p:nvSpPr>
         <p:spPr>
           <a:xfrm>
-            <a:off x="1737360" y="6119655"/>
+            <a:off x="1737360" y="5161193"/>
             <a:ext cx="8686800" cy="365760"/>
           </a:xfrm>
           <a:prstGeom prst="rect">
@@ -3427,7 +3428,7 @@
               </a:defRPr>
             </a:pPr>
             <a:r>
-              <a:t>Splitwise Figure 3: Input/output token length distributions from two Azure LLM services</a:t>
+              <a:t>Source: Patel et al., ISCA 2024, Figure 3</a:t>
             </a:r>
           </a:p>
         </p:txBody>
@@ -4804,7 +4805,7 @@
         <p:spPr>
           <a:xfrm>
             <a:off x="1737360" y="1097280"/>
-            <a:ext cx="8686800" cy="8319062"/>
+            <a:ext cx="8686800" cy="8883668"/>
           </a:xfrm>
           <a:prstGeom prst="rect">
             <a:avLst/>
@@ -4819,7 +4820,7 @@
         </p:nvSpPr>
         <p:spPr>
           <a:xfrm>
-            <a:off x="1737360" y="9553502"/>
+            <a:off x="1737360" y="10118108"/>
             <a:ext cx="8686800" cy="365760"/>
           </a:xfrm>
           <a:prstGeom prst="rect">
@@ -4842,7 +4843,7 @@
               </a:defRPr>
             </a:pPr>
             <a:r>
-              <a:t>Splitwise Figure 10: Three-pool architecture with cluster-level scheduling</a:t>
+              <a:t>Source: Patel et al., ISCA 2024, Figure 10</a:t>
             </a:r>
           </a:p>
         </p:txBody>
@@ -6395,7 +6396,7 @@
         <p:spPr>
           <a:xfrm>
             <a:off x="1737360" y="1097280"/>
-            <a:ext cx="8686800" cy="12213037"/>
+            <a:ext cx="8686800" cy="7088147"/>
           </a:xfrm>
           <a:prstGeom prst="rect">
             <a:avLst/>
@@ -6410,7 +6411,7 @@
         </p:nvSpPr>
         <p:spPr>
           <a:xfrm>
-            <a:off x="1737360" y="13447477"/>
+            <a:off x="1737360" y="8322587"/>
             <a:ext cx="8686800" cy="365760"/>
           </a:xfrm>
           <a:prstGeom prst="rect">
@@ -6433,7 +6434,7 @@
               </a:defRPr>
             </a:pPr>
             <a:r>
-              <a:t>Splitwise Figure 16: Throughput vs latency across cluster configurations</a:t>
+              <a:t>Source: Patel et al., ISCA 2024, Figure 16</a:t>
             </a:r>
           </a:p>
         </p:txBody>
@@ -8018,7 +8019,7 @@
         <p:spPr>
           <a:xfrm>
             <a:off x="1737360" y="1097280"/>
-            <a:ext cx="8686800" cy="6350779"/>
+            <a:ext cx="8686800" cy="4711219"/>
           </a:xfrm>
           <a:prstGeom prst="rect">
             <a:avLst/>
@@ -8033,7 +8034,7 @@
         </p:nvSpPr>
         <p:spPr>
           <a:xfrm>
-            <a:off x="1737360" y="7585219"/>
+            <a:off x="1737360" y="5945659"/>
             <a:ext cx="8686800" cy="365760"/>
           </a:xfrm>
           <a:prstGeom prst="rect">
@@ -8056,7 +8057,7 @@
               </a:defRPr>
             </a:pPr>
             <a:r>
-              <a:t>DistServe Figure 6: Disaggregated prefill and decoding with pull-based KV-cache transfer</a:t>
+              <a:t>Source: Zhong et al., OSDI 2024, Figure 6</a:t>
             </a:r>
           </a:p>
         </p:txBody>
@@ -9496,7 +9497,7 @@
         <p:spPr>
           <a:xfrm>
             <a:off x="1737360" y="1097280"/>
-            <a:ext cx="8686800" cy="3511323"/>
+            <a:ext cx="8686800" cy="4175268"/>
           </a:xfrm>
           <a:prstGeom prst="rect">
             <a:avLst/>
@@ -9511,7 +9512,7 @@
         </p:nvSpPr>
         <p:spPr>
           <a:xfrm>
-            <a:off x="1737360" y="4745763"/>
+            <a:off x="1737360" y="5409708"/>
             <a:ext cx="8686800" cy="365760"/>
           </a:xfrm>
           <a:prstGeom prst="rect">
@@ -9534,7 +9535,7 @@
               </a:defRPr>
             </a:pPr>
             <a:r>
-              <a:t>DistServe Figure 8: Goodput comparison on ShareGPT workload across OPT model sizes</a:t>
+              <a:t>Source: Zhong et al., OSDI 2024, Figure 8</a:t>
             </a:r>
           </a:p>
         </p:txBody>
@@ -9618,7 +9619,7 @@
         <p:spPr>
           <a:xfrm>
             <a:off x="1737360" y="1097280"/>
-            <a:ext cx="8686800" cy="1872706"/>
+            <a:ext cx="8686800" cy="2705004"/>
           </a:xfrm>
           <a:prstGeom prst="rect">
             <a:avLst/>
@@ -9633,7 +9634,7 @@
         </p:nvSpPr>
         <p:spPr>
           <a:xfrm>
-            <a:off x="1737360" y="3107146"/>
+            <a:off x="1737360" y="3939444"/>
             <a:ext cx="8686800" cy="365760"/>
           </a:xfrm>
           <a:prstGeom prst="rect">
@@ -9656,7 +9657,7 @@
               </a:defRPr>
             </a:pPr>
             <a:r>
-              <a:t>DistServe Figure 9: HumanEval (code completion) and LongBench (summarization) results</a:t>
+              <a:t>Source: Zhong et al., OSDI 2024, Figure 9</a:t>
             </a:r>
           </a:p>
         </p:txBody>
@@ -10088,7 +10089,7 @@
         <p:spPr>
           <a:xfrm>
             <a:off x="1737360" y="1097280"/>
-            <a:ext cx="8686800" cy="6110960"/>
+            <a:ext cx="8686800" cy="5376920"/>
           </a:xfrm>
           <a:prstGeom prst="rect">
             <a:avLst/>
@@ -10103,7 +10104,7 @@
         </p:nvSpPr>
         <p:spPr>
           <a:xfrm>
-            <a:off x="1737360" y="7345400"/>
+            <a:off x="1737360" y="6611360"/>
             <a:ext cx="8686800" cy="365760"/>
           </a:xfrm>
           <a:prstGeom prst="rect">
@@ -10126,7 +10127,7 @@
               </a:defRPr>
             </a:pPr>
             <a:r>
-              <a:t>DistServe Figure 10: CDF of TTFT and TPOT, disaggregated vs colocated serving</a:t>
+              <a:t>Source: Zhong et al., OSDI 2024, Figure 10</a:t>
             </a:r>
           </a:p>
         </p:txBody>
@@ -12256,6 +12257,332 @@
     <p:bg>
       <p:bgPr>
         <a:solidFill>
+          <a:srgbClr val="FFFFFF"/>
+        </a:solidFill>
+        <a:effectLst/>
+      </p:bgPr>
+    </p:bg>
+    <p:spTree>
+      <p:nvGrpSpPr>
+        <p:cNvPr id="1" name=""/>
+        <p:cNvGrpSpPr/>
+        <p:nvPr/>
+      </p:nvGrpSpPr>
+      <p:grpSpPr/>
+      <p:sp>
+        <p:nvSpPr>
+          <p:cNvPr id="2" name="TextBox 1"/>
+          <p:cNvSpPr txBox="1"/>
+          <p:nvPr/>
+        </p:nvSpPr>
+        <p:spPr>
+          <a:xfrm>
+            <a:off x="1097280" y="457200"/>
+            <a:ext cx="10058400" cy="640080"/>
+          </a:xfrm>
+          <a:prstGeom prst="rect">
+            <a:avLst/>
+          </a:prstGeom>
+          <a:noFill/>
+        </p:spPr>
+        <p:txBody>
+          <a:bodyPr wrap="square">
+            <a:spAutoFit/>
+          </a:bodyPr>
+          <a:lstStyle/>
+          <a:p>
+            <a:pPr algn="l">
+              <a:defRPr sz="3400" b="1">
+                <a:solidFill>
+                  <a:srgbClr val="1A1A1A"/>
+                </a:solidFill>
+                <a:latin typeface="Palatino Linotype"/>
+              </a:defRPr>
+            </a:pPr>
+            <a:r>
+              <a:t>References</a:t>
+            </a:r>
+          </a:p>
+        </p:txBody>
+      </p:sp>
+      <p:sp>
+        <p:nvSpPr>
+          <p:cNvPr id="3" name="TextBox 2"/>
+          <p:cNvSpPr txBox="1"/>
+          <p:nvPr/>
+        </p:nvSpPr>
+        <p:spPr>
+          <a:xfrm>
+            <a:off x="1097280" y="1371600"/>
+            <a:ext cx="9601200" cy="5029200"/>
+          </a:xfrm>
+          <a:prstGeom prst="rect">
+            <a:avLst/>
+          </a:prstGeom>
+          <a:noFill/>
+        </p:spPr>
+        <p:txBody>
+          <a:bodyPr wrap="square">
+            <a:spAutoFit/>
+          </a:bodyPr>
+          <a:lstStyle/>
+          <a:p>
+            <a:pPr algn="l">
+              <a:defRPr sz="1300" b="0">
+                <a:solidFill>
+                  <a:srgbClr val="333333"/>
+                </a:solidFill>
+                <a:latin typeface="Palatino Linotype"/>
+              </a:defRPr>
+            </a:pPr>
+            <a:r>
+              <a:t>[1]  P. Patel, E. Choukse, C. Zhang, A. Shah, I. Goiri, S. Maleki, R. Bianchini.</a:t>
+            </a:r>
+          </a:p>
+          <a:p>
+            <a:pPr algn="l">
+              <a:spcBef>
+                <a:spcPts val="100"/>
+              </a:spcBef>
+              <a:defRPr sz="1300" b="0">
+                <a:solidFill>
+                  <a:srgbClr val="333333"/>
+                </a:solidFill>
+                <a:latin typeface="Palatino Linotype"/>
+              </a:defRPr>
+            </a:pPr>
+            <a:r>
+              <a:t>     "Splitwise: Efficient Generative LLM Inference Using Phase Splitting."</a:t>
+            </a:r>
+          </a:p>
+          <a:p>
+            <a:pPr algn="l">
+              <a:spcBef>
+                <a:spcPts val="100"/>
+              </a:spcBef>
+              <a:defRPr sz="1300" b="0">
+                <a:solidFill>
+                  <a:srgbClr val="333333"/>
+                </a:solidFill>
+                <a:latin typeface="Palatino Linotype"/>
+              </a:defRPr>
+            </a:pPr>
+            <a:r>
+              <a:t>     ISCA 2024. arXiv:2311.18677</a:t>
+            </a:r>
+          </a:p>
+          <a:p>
+            <a:pPr algn="l">
+              <a:spcBef>
+                <a:spcPts val="100"/>
+              </a:spcBef>
+              <a:defRPr sz="1300" b="0">
+                <a:solidFill>
+                  <a:srgbClr val="333333"/>
+                </a:solidFill>
+                <a:latin typeface="Palatino Linotype"/>
+              </a:defRPr>
+            </a:pPr>
+          </a:p>
+          <a:p>
+            <a:pPr algn="l">
+              <a:spcBef>
+                <a:spcPts val="100"/>
+              </a:spcBef>
+              <a:defRPr sz="1300" b="0">
+                <a:solidFill>
+                  <a:srgbClr val="333333"/>
+                </a:solidFill>
+                <a:latin typeface="Palatino Linotype"/>
+              </a:defRPr>
+            </a:pPr>
+            <a:r>
+              <a:t>[2]  Y. Zhong, S. Liu, J. Chen, J. Hu, Y. Zhu, X. Liu, X. Jin, H. Zhang.</a:t>
+            </a:r>
+          </a:p>
+          <a:p>
+            <a:pPr algn="l">
+              <a:spcBef>
+                <a:spcPts val="100"/>
+              </a:spcBef>
+              <a:defRPr sz="1300" b="0">
+                <a:solidFill>
+                  <a:srgbClr val="333333"/>
+                </a:solidFill>
+                <a:latin typeface="Palatino Linotype"/>
+              </a:defRPr>
+            </a:pPr>
+            <a:r>
+              <a:t>     "DistServe: Disaggregating Prefill and Decoding for Goodput-optimized</a:t>
+            </a:r>
+          </a:p>
+          <a:p>
+            <a:pPr algn="l">
+              <a:spcBef>
+                <a:spcPts val="100"/>
+              </a:spcBef>
+              <a:defRPr sz="1300" b="0">
+                <a:solidFill>
+                  <a:srgbClr val="333333"/>
+                </a:solidFill>
+                <a:latin typeface="Palatino Linotype"/>
+              </a:defRPr>
+            </a:pPr>
+            <a:r>
+              <a:t>     Large Language Model Serving."  OSDI 2024. arXiv:2401.09670</a:t>
+            </a:r>
+          </a:p>
+          <a:p>
+            <a:pPr algn="l">
+              <a:spcBef>
+                <a:spcPts val="100"/>
+              </a:spcBef>
+              <a:defRPr sz="1300" b="0">
+                <a:solidFill>
+                  <a:srgbClr val="333333"/>
+                </a:solidFill>
+                <a:latin typeface="Palatino Linotype"/>
+              </a:defRPr>
+            </a:pPr>
+          </a:p>
+          <a:p>
+            <a:pPr algn="l">
+              <a:spcBef>
+                <a:spcPts val="100"/>
+              </a:spcBef>
+              <a:defRPr sz="1300" b="0">
+                <a:solidFill>
+                  <a:srgbClr val="333333"/>
+                </a:solidFill>
+                <a:latin typeface="Palatino Linotype"/>
+              </a:defRPr>
+            </a:pPr>
+            <a:r>
+              <a:t>[3]  A. Agrawal et al. Sarathi: Efficient LLM Inference by Piggybacking Decodes</a:t>
+            </a:r>
+          </a:p>
+          <a:p>
+            <a:pPr algn="l">
+              <a:spcBef>
+                <a:spcPts val="100"/>
+              </a:spcBef>
+              <a:defRPr sz="1300" b="0">
+                <a:solidFill>
+                  <a:srgbClr val="333333"/>
+                </a:solidFill>
+                <a:latin typeface="Palatino Linotype"/>
+              </a:defRPr>
+            </a:pPr>
+            <a:r>
+              <a:t>     with Chunked Prefills. arXiv:2308.16369, 2023.</a:t>
+            </a:r>
+          </a:p>
+          <a:p>
+            <a:pPr algn="l">
+              <a:spcBef>
+                <a:spcPts val="100"/>
+              </a:spcBef>
+              <a:defRPr sz="1300" b="0">
+                <a:solidFill>
+                  <a:srgbClr val="333333"/>
+                </a:solidFill>
+                <a:latin typeface="Palatino Linotype"/>
+              </a:defRPr>
+            </a:pPr>
+          </a:p>
+          <a:p>
+            <a:pPr algn="l">
+              <a:spcBef>
+                <a:spcPts val="100"/>
+              </a:spcBef>
+              <a:defRPr sz="1300" b="0">
+                <a:solidFill>
+                  <a:srgbClr val="333333"/>
+                </a:solidFill>
+                <a:latin typeface="Palatino Linotype"/>
+              </a:defRPr>
+            </a:pPr>
+            <a:r>
+              <a:t>[4]  W. Kwon et al. Efficient Memory Management for Large Language Model Serving</a:t>
+            </a:r>
+          </a:p>
+          <a:p>
+            <a:pPr algn="l">
+              <a:spcBef>
+                <a:spcPts val="100"/>
+              </a:spcBef>
+              <a:defRPr sz="1300" b="0">
+                <a:solidFill>
+                  <a:srgbClr val="333333"/>
+                </a:solidFill>
+                <a:latin typeface="Palatino Linotype"/>
+              </a:defRPr>
+            </a:pPr>
+            <a:r>
+              <a:t>     with PagedAttention (vLLM). SOSP 2023.</a:t>
+            </a:r>
+          </a:p>
+          <a:p>
+            <a:pPr algn="l">
+              <a:spcBef>
+                <a:spcPts val="100"/>
+              </a:spcBef>
+              <a:defRPr sz="1300" b="0">
+                <a:solidFill>
+                  <a:srgbClr val="333333"/>
+                </a:solidFill>
+                <a:latin typeface="Palatino Linotype"/>
+              </a:defRPr>
+            </a:pPr>
+          </a:p>
+          <a:p>
+            <a:pPr algn="l">
+              <a:spcBef>
+                <a:spcPts val="100"/>
+              </a:spcBef>
+              <a:defRPr sz="1300" b="0">
+                <a:solidFill>
+                  <a:srgbClr val="333333"/>
+                </a:solidFill>
+                <a:latin typeface="Palatino Linotype"/>
+              </a:defRPr>
+            </a:pPr>
+            <a:r>
+              <a:t>[5]  Y. Sheng et al. FlexGen: High-Throughput Generative Inference of Large Language</a:t>
+            </a:r>
+          </a:p>
+          <a:p>
+            <a:pPr algn="l">
+              <a:spcBef>
+                <a:spcPts val="100"/>
+              </a:spcBef>
+              <a:defRPr sz="1300" b="0">
+                <a:solidFill>
+                  <a:srgbClr val="333333"/>
+                </a:solidFill>
+                <a:latin typeface="Palatino Linotype"/>
+              </a:defRPr>
+            </a:pPr>
+            <a:r>
+              <a:t>     Models with a Single GPU. ICML 2023.</a:t>
+            </a:r>
+          </a:p>
+        </p:txBody>
+      </p:sp>
+    </p:spTree>
+  </p:cSld>
+  <p:clrMapOvr>
+    <a:masterClrMapping/>
+  </p:clrMapOvr>
+</p:sld>
+</file>
+
+<file path=ppt/slides/slide33.xml><?xml version="1.0" encoding="utf-8"?>
+<p:sld xmlns:a="http://schemas.openxmlformats.org/drawingml/2006/main" xmlns:p="http://schemas.openxmlformats.org/presentationml/2006/main" xmlns:r="http://schemas.openxmlformats.org/officeDocument/2006/relationships">
+  <p:cSld>
+    <p:bg>
+      <p:bgPr>
+        <a:solidFill>
           <a:srgbClr val="0F172A"/>
         </a:solidFill>
         <a:effectLst/>
@@ -14529,7 +14856,7 @@
         <p:spPr>
           <a:xfrm>
             <a:off x="1737360" y="1097280"/>
-            <a:ext cx="8686800" cy="4494581"/>
+            <a:ext cx="8686800" cy="4454101"/>
           </a:xfrm>
           <a:prstGeom prst="rect">
             <a:avLst/>
@@ -14544,7 +14871,7 @@
         </p:nvSpPr>
         <p:spPr>
           <a:xfrm>
-            <a:off x="1737360" y="5729021"/>
+            <a:off x="1737360" y="5688541"/>
             <a:ext cx="8686800" cy="365760"/>
           </a:xfrm>
           <a:prstGeom prst="rect">
@@ -14567,7 +14894,7 @@
               </a:defRPr>
             </a:pPr>
             <a:r>
-              <a:t>DistServe Figure 2: Decoding latency degrades up to 3-5x when colocated with prefill</a:t>
+              <a:t>Source: Zhong et al., OSDI 2024, Figure 2</a:t>
             </a:r>
           </a:p>
         </p:txBody>

</xml_diff>

<commit_message>
feat: add slide numbers to PPTX and scripts
- Slide numbers displayed bottom-right on every slide (except title)
- Both scripts now show SLIDE N: Title format for easy matching
- Split Cluster Designs & Results into slides 15/16
- Merged Ethan's script sections to match actual PPTX slides 1:1
- Regenerated all PDFs
</commit_message>
<xml_diff>
--- a/presentation/Phase_Disaggregation_LLM_Inference.pptx
+++ b/presentation/Phase_Disaggregation_LLM_Inference.pptx
@@ -3429,6 +3429,42 @@
             </a:pPr>
             <a:r>
               <a:t>Source: Patel et al., ISCA 2024, Figure 3</a:t>
+            </a:r>
+          </a:p>
+        </p:txBody>
+      </p:sp>
+      <p:sp>
+        <p:nvSpPr>
+          <p:cNvPr id="5" name="TextBox 4"/>
+          <p:cNvSpPr txBox="1"/>
+          <p:nvPr/>
+        </p:nvSpPr>
+        <p:spPr>
+          <a:xfrm>
+            <a:off x="11338560" y="6446520"/>
+            <a:ext cx="640080" cy="320040"/>
+          </a:xfrm>
+          <a:prstGeom prst="rect">
+            <a:avLst/>
+          </a:prstGeom>
+          <a:noFill/>
+        </p:spPr>
+        <p:txBody>
+          <a:bodyPr wrap="square">
+            <a:spAutoFit/>
+          </a:bodyPr>
+          <a:lstStyle/>
+          <a:p>
+            <a:pPr algn="r">
+              <a:defRPr sz="1000" b="0">
+                <a:solidFill>
+                  <a:srgbClr val="AAAAAA"/>
+                </a:solidFill>
+                <a:latin typeface="Palatino Linotype"/>
+              </a:defRPr>
+            </a:pPr>
+            <a:r>
+              <a:t>10</a:t>
             </a:r>
           </a:p>
         </p:txBody>
@@ -4157,6 +4193,42 @@
           </a:p>
         </p:txBody>
       </p:sp>
+      <p:sp>
+        <p:nvSpPr>
+          <p:cNvPr id="7" name="TextBox 6"/>
+          <p:cNvSpPr txBox="1"/>
+          <p:nvPr/>
+        </p:nvSpPr>
+        <p:spPr>
+          <a:xfrm>
+            <a:off x="11338560" y="6446520"/>
+            <a:ext cx="640080" cy="320040"/>
+          </a:xfrm>
+          <a:prstGeom prst="rect">
+            <a:avLst/>
+          </a:prstGeom>
+          <a:noFill/>
+        </p:spPr>
+        <p:txBody>
+          <a:bodyPr wrap="square">
+            <a:spAutoFit/>
+          </a:bodyPr>
+          <a:lstStyle/>
+          <a:p>
+            <a:pPr algn="r">
+              <a:defRPr sz="1000" b="0">
+                <a:solidFill>
+                  <a:srgbClr val="AAAAAA"/>
+                </a:solidFill>
+                <a:latin typeface="Palatino Linotype"/>
+              </a:defRPr>
+            </a:pPr>
+            <a:r>
+              <a:t>11</a:t>
+            </a:r>
+          </a:p>
+        </p:txBody>
+      </p:sp>
     </p:spTree>
   </p:cSld>
   <p:clrMapOvr>
@@ -4726,6 +4798,42 @@
           </a:p>
         </p:txBody>
       </p:sp>
+      <p:sp>
+        <p:nvSpPr>
+          <p:cNvPr id="13" name="TextBox 12"/>
+          <p:cNvSpPr txBox="1"/>
+          <p:nvPr/>
+        </p:nvSpPr>
+        <p:spPr>
+          <a:xfrm>
+            <a:off x="11338560" y="6446520"/>
+            <a:ext cx="640080" cy="320040"/>
+          </a:xfrm>
+          <a:prstGeom prst="rect">
+            <a:avLst/>
+          </a:prstGeom>
+          <a:noFill/>
+        </p:spPr>
+        <p:txBody>
+          <a:bodyPr wrap="square">
+            <a:spAutoFit/>
+          </a:bodyPr>
+          <a:lstStyle/>
+          <a:p>
+            <a:pPr algn="r">
+              <a:defRPr sz="1000" b="0">
+                <a:solidFill>
+                  <a:srgbClr val="AAAAAA"/>
+                </a:solidFill>
+                <a:latin typeface="Palatino Linotype"/>
+              </a:defRPr>
+            </a:pPr>
+            <a:r>
+              <a:t>12</a:t>
+            </a:r>
+          </a:p>
+        </p:txBody>
+      </p:sp>
     </p:spTree>
   </p:cSld>
   <p:clrMapOvr>
@@ -4848,6 +4956,42 @@
           </a:p>
         </p:txBody>
       </p:sp>
+      <p:sp>
+        <p:nvSpPr>
+          <p:cNvPr id="5" name="TextBox 4"/>
+          <p:cNvSpPr txBox="1"/>
+          <p:nvPr/>
+        </p:nvSpPr>
+        <p:spPr>
+          <a:xfrm>
+            <a:off x="11338560" y="6446520"/>
+            <a:ext cx="640080" cy="320040"/>
+          </a:xfrm>
+          <a:prstGeom prst="rect">
+            <a:avLst/>
+          </a:prstGeom>
+          <a:noFill/>
+        </p:spPr>
+        <p:txBody>
+          <a:bodyPr wrap="square">
+            <a:spAutoFit/>
+          </a:bodyPr>
+          <a:lstStyle/>
+          <a:p>
+            <a:pPr algn="r">
+              <a:defRPr sz="1000" b="0">
+                <a:solidFill>
+                  <a:srgbClr val="AAAAAA"/>
+                </a:solidFill>
+                <a:latin typeface="Palatino Linotype"/>
+              </a:defRPr>
+            </a:pPr>
+            <a:r>
+              <a:t>13</a:t>
+            </a:r>
+          </a:p>
+        </p:txBody>
+      </p:sp>
     </p:spTree>
   </p:cSld>
   <p:clrMapOvr>
@@ -5271,6 +5415,42 @@
             </a:pPr>
             <a:r>
               <a:t>Both papers confirm: KV-cache transfer is not the bottleneck.</a:t>
+            </a:r>
+          </a:p>
+        </p:txBody>
+      </p:sp>
+      <p:sp>
+        <p:nvSpPr>
+          <p:cNvPr id="9" name="TextBox 8"/>
+          <p:cNvSpPr txBox="1"/>
+          <p:nvPr/>
+        </p:nvSpPr>
+        <p:spPr>
+          <a:xfrm>
+            <a:off x="11338560" y="6446520"/>
+            <a:ext cx="640080" cy="320040"/>
+          </a:xfrm>
+          <a:prstGeom prst="rect">
+            <a:avLst/>
+          </a:prstGeom>
+          <a:noFill/>
+        </p:spPr>
+        <p:txBody>
+          <a:bodyPr wrap="square">
+            <a:spAutoFit/>
+          </a:bodyPr>
+          <a:lstStyle/>
+          <a:p>
+            <a:pPr algn="r">
+              <a:defRPr sz="1000" b="0">
+                <a:solidFill>
+                  <a:srgbClr val="AAAAAA"/>
+                </a:solidFill>
+                <a:latin typeface="Palatino Linotype"/>
+              </a:defRPr>
+            </a:pPr>
+            <a:r>
+              <a:t>14</a:t>
             </a:r>
           </a:p>
         </p:txBody>
@@ -5855,6 +6035,42 @@
           </a:graphicData>
         </a:graphic>
       </p:graphicFrame>
+      <p:sp>
+        <p:nvSpPr>
+          <p:cNvPr id="4" name="TextBox 3"/>
+          <p:cNvSpPr txBox="1"/>
+          <p:nvPr/>
+        </p:nvSpPr>
+        <p:spPr>
+          <a:xfrm>
+            <a:off x="11338560" y="6446520"/>
+            <a:ext cx="640080" cy="320040"/>
+          </a:xfrm>
+          <a:prstGeom prst="rect">
+            <a:avLst/>
+          </a:prstGeom>
+          <a:noFill/>
+        </p:spPr>
+        <p:txBody>
+          <a:bodyPr wrap="square">
+            <a:spAutoFit/>
+          </a:bodyPr>
+          <a:lstStyle/>
+          <a:p>
+            <a:pPr algn="r">
+              <a:defRPr sz="1000" b="0">
+                <a:solidFill>
+                  <a:srgbClr val="AAAAAA"/>
+                </a:solidFill>
+                <a:latin typeface="Palatino Linotype"/>
+              </a:defRPr>
+            </a:pPr>
+            <a:r>
+              <a:t>15</a:t>
+            </a:r>
+          </a:p>
+        </p:txBody>
+      </p:sp>
     </p:spTree>
   </p:cSld>
   <p:clrMapOvr>
@@ -6317,6 +6533,42 @@
           </a:p>
         </p:txBody>
       </p:sp>
+      <p:sp>
+        <p:nvSpPr>
+          <p:cNvPr id="12" name="TextBox 11"/>
+          <p:cNvSpPr txBox="1"/>
+          <p:nvPr/>
+        </p:nvSpPr>
+        <p:spPr>
+          <a:xfrm>
+            <a:off x="11338560" y="6446520"/>
+            <a:ext cx="640080" cy="320040"/>
+          </a:xfrm>
+          <a:prstGeom prst="rect">
+            <a:avLst/>
+          </a:prstGeom>
+          <a:noFill/>
+        </p:spPr>
+        <p:txBody>
+          <a:bodyPr wrap="square">
+            <a:spAutoFit/>
+          </a:bodyPr>
+          <a:lstStyle/>
+          <a:p>
+            <a:pPr algn="r">
+              <a:defRPr sz="1000" b="0">
+                <a:solidFill>
+                  <a:srgbClr val="AAAAAA"/>
+                </a:solidFill>
+                <a:latin typeface="Palatino Linotype"/>
+              </a:defRPr>
+            </a:pPr>
+            <a:r>
+              <a:t>16</a:t>
+            </a:r>
+          </a:p>
+        </p:txBody>
+      </p:sp>
     </p:spTree>
   </p:cSld>
   <p:clrMapOvr>
@@ -6439,6 +6691,42 @@
           </a:p>
         </p:txBody>
       </p:sp>
+      <p:sp>
+        <p:nvSpPr>
+          <p:cNvPr id="5" name="TextBox 4"/>
+          <p:cNvSpPr txBox="1"/>
+          <p:nvPr/>
+        </p:nvSpPr>
+        <p:spPr>
+          <a:xfrm>
+            <a:off x="11338560" y="6446520"/>
+            <a:ext cx="640080" cy="320040"/>
+          </a:xfrm>
+          <a:prstGeom prst="rect">
+            <a:avLst/>
+          </a:prstGeom>
+          <a:noFill/>
+        </p:spPr>
+        <p:txBody>
+          <a:bodyPr wrap="square">
+            <a:spAutoFit/>
+          </a:bodyPr>
+          <a:lstStyle/>
+          <a:p>
+            <a:pPr algn="r">
+              <a:defRPr sz="1000" b="0">
+                <a:solidFill>
+                  <a:srgbClr val="AAAAAA"/>
+                </a:solidFill>
+                <a:latin typeface="Palatino Linotype"/>
+              </a:defRPr>
+            </a:pPr>
+            <a:r>
+              <a:t>17</a:t>
+            </a:r>
+          </a:p>
+        </p:txBody>
+      </p:sp>
     </p:spTree>
   </p:cSld>
   <p:clrMapOvr>
@@ -6693,6 +6981,42 @@
           </a:p>
         </p:txBody>
       </p:sp>
+      <p:sp>
+        <p:nvSpPr>
+          <p:cNvPr id="6" name="TextBox 5"/>
+          <p:cNvSpPr txBox="1"/>
+          <p:nvPr/>
+        </p:nvSpPr>
+        <p:spPr>
+          <a:xfrm>
+            <a:off x="11338560" y="6446520"/>
+            <a:ext cx="640080" cy="320040"/>
+          </a:xfrm>
+          <a:prstGeom prst="rect">
+            <a:avLst/>
+          </a:prstGeom>
+          <a:noFill/>
+        </p:spPr>
+        <p:txBody>
+          <a:bodyPr wrap="square">
+            <a:spAutoFit/>
+          </a:bodyPr>
+          <a:lstStyle/>
+          <a:p>
+            <a:pPr algn="r">
+              <a:defRPr sz="1000" b="0">
+                <a:solidFill>
+                  <a:srgbClr val="AAAAAA"/>
+                </a:solidFill>
+                <a:latin typeface="Palatino Linotype"/>
+              </a:defRPr>
+            </a:pPr>
+            <a:r>
+              <a:t>18</a:t>
+            </a:r>
+          </a:p>
+        </p:txBody>
+      </p:sp>
     </p:spTree>
   </p:cSld>
   <p:clrMapOvr>
@@ -6850,6 +7174,42 @@
           </a:p>
         </p:txBody>
       </p:sp>
+      <p:sp>
+        <p:nvSpPr>
+          <p:cNvPr id="5" name="TextBox 4"/>
+          <p:cNvSpPr txBox="1"/>
+          <p:nvPr/>
+        </p:nvSpPr>
+        <p:spPr>
+          <a:xfrm>
+            <a:off x="11338560" y="6446520"/>
+            <a:ext cx="640080" cy="320040"/>
+          </a:xfrm>
+          <a:prstGeom prst="rect">
+            <a:avLst/>
+          </a:prstGeom>
+          <a:noFill/>
+        </p:spPr>
+        <p:txBody>
+          <a:bodyPr wrap="square">
+            <a:spAutoFit/>
+          </a:bodyPr>
+          <a:lstStyle/>
+          <a:p>
+            <a:pPr algn="r">
+              <a:defRPr sz="1000" b="0">
+                <a:solidFill>
+                  <a:srgbClr val="556688"/>
+                </a:solidFill>
+                <a:latin typeface="Palatino Linotype"/>
+              </a:defRPr>
+            </a:pPr>
+            <a:r>
+              <a:t>19</a:t>
+            </a:r>
+          </a:p>
+        </p:txBody>
+      </p:sp>
     </p:spTree>
   </p:cSld>
   <p:clrMapOvr>
@@ -7192,6 +7552,42 @@
           </a:p>
         </p:txBody>
       </p:sp>
+      <p:sp>
+        <p:nvSpPr>
+          <p:cNvPr id="5" name="TextBox 4"/>
+          <p:cNvSpPr txBox="1"/>
+          <p:nvPr/>
+        </p:nvSpPr>
+        <p:spPr>
+          <a:xfrm>
+            <a:off x="11338560" y="6446520"/>
+            <a:ext cx="640080" cy="320040"/>
+          </a:xfrm>
+          <a:prstGeom prst="rect">
+            <a:avLst/>
+          </a:prstGeom>
+          <a:noFill/>
+        </p:spPr>
+        <p:txBody>
+          <a:bodyPr wrap="square">
+            <a:spAutoFit/>
+          </a:bodyPr>
+          <a:lstStyle/>
+          <a:p>
+            <a:pPr algn="r">
+              <a:defRPr sz="1000" b="0">
+                <a:solidFill>
+                  <a:srgbClr val="AAAAAA"/>
+                </a:solidFill>
+                <a:latin typeface="Palatino Linotype"/>
+              </a:defRPr>
+            </a:pPr>
+            <a:r>
+              <a:t>2</a:t>
+            </a:r>
+          </a:p>
+        </p:txBody>
+      </p:sp>
     </p:spTree>
   </p:cSld>
   <p:clrMapOvr>
@@ -7449,6 +7845,42 @@
           </a:p>
         </p:txBody>
       </p:sp>
+      <p:sp>
+        <p:nvSpPr>
+          <p:cNvPr id="6" name="TextBox 5"/>
+          <p:cNvSpPr txBox="1"/>
+          <p:nvPr/>
+        </p:nvSpPr>
+        <p:spPr>
+          <a:xfrm>
+            <a:off x="11338560" y="6446520"/>
+            <a:ext cx="640080" cy="320040"/>
+          </a:xfrm>
+          <a:prstGeom prst="rect">
+            <a:avLst/>
+          </a:prstGeom>
+          <a:noFill/>
+        </p:spPr>
+        <p:txBody>
+          <a:bodyPr wrap="square">
+            <a:spAutoFit/>
+          </a:bodyPr>
+          <a:lstStyle/>
+          <a:p>
+            <a:pPr algn="r">
+              <a:defRPr sz="1000" b="0">
+                <a:solidFill>
+                  <a:srgbClr val="AAAAAA"/>
+                </a:solidFill>
+                <a:latin typeface="Palatino Linotype"/>
+              </a:defRPr>
+            </a:pPr>
+            <a:r>
+              <a:t>20</a:t>
+            </a:r>
+          </a:p>
+        </p:txBody>
+      </p:sp>
     </p:spTree>
   </p:cSld>
   <p:clrMapOvr>
@@ -7940,6 +8372,42 @@
           </a:p>
         </p:txBody>
       </p:sp>
+      <p:sp>
+        <p:nvSpPr>
+          <p:cNvPr id="9" name="TextBox 8"/>
+          <p:cNvSpPr txBox="1"/>
+          <p:nvPr/>
+        </p:nvSpPr>
+        <p:spPr>
+          <a:xfrm>
+            <a:off x="11338560" y="6446520"/>
+            <a:ext cx="640080" cy="320040"/>
+          </a:xfrm>
+          <a:prstGeom prst="rect">
+            <a:avLst/>
+          </a:prstGeom>
+          <a:noFill/>
+        </p:spPr>
+        <p:txBody>
+          <a:bodyPr wrap="square">
+            <a:spAutoFit/>
+          </a:bodyPr>
+          <a:lstStyle/>
+          <a:p>
+            <a:pPr algn="r">
+              <a:defRPr sz="1000" b="0">
+                <a:solidFill>
+                  <a:srgbClr val="AAAAAA"/>
+                </a:solidFill>
+                <a:latin typeface="Palatino Linotype"/>
+              </a:defRPr>
+            </a:pPr>
+            <a:r>
+              <a:t>21</a:t>
+            </a:r>
+          </a:p>
+        </p:txBody>
+      </p:sp>
     </p:spTree>
   </p:cSld>
   <p:clrMapOvr>
@@ -8062,6 +8530,42 @@
           </a:p>
         </p:txBody>
       </p:sp>
+      <p:sp>
+        <p:nvSpPr>
+          <p:cNvPr id="5" name="TextBox 4"/>
+          <p:cNvSpPr txBox="1"/>
+          <p:nvPr/>
+        </p:nvSpPr>
+        <p:spPr>
+          <a:xfrm>
+            <a:off x="11338560" y="6446520"/>
+            <a:ext cx="640080" cy="320040"/>
+          </a:xfrm>
+          <a:prstGeom prst="rect">
+            <a:avLst/>
+          </a:prstGeom>
+          <a:noFill/>
+        </p:spPr>
+        <p:txBody>
+          <a:bodyPr wrap="square">
+            <a:spAutoFit/>
+          </a:bodyPr>
+          <a:lstStyle/>
+          <a:p>
+            <a:pPr algn="r">
+              <a:defRPr sz="1000" b="0">
+                <a:solidFill>
+                  <a:srgbClr val="AAAAAA"/>
+                </a:solidFill>
+                <a:latin typeface="Palatino Linotype"/>
+              </a:defRPr>
+            </a:pPr>
+            <a:r>
+              <a:t>22</a:t>
+            </a:r>
+          </a:p>
+        </p:txBody>
+      </p:sp>
     </p:spTree>
   </p:cSld>
   <p:clrMapOvr>
@@ -8537,6 +9041,42 @@
             </a:pPr>
             <a:r>
               <a:t>Simulator accuracy: under 2% error compared to real hardware runs</a:t>
+            </a:r>
+          </a:p>
+        </p:txBody>
+      </p:sp>
+      <p:sp>
+        <p:nvSpPr>
+          <p:cNvPr id="10" name="TextBox 9"/>
+          <p:cNvSpPr txBox="1"/>
+          <p:nvPr/>
+        </p:nvSpPr>
+        <p:spPr>
+          <a:xfrm>
+            <a:off x="11338560" y="6446520"/>
+            <a:ext cx="640080" cy="320040"/>
+          </a:xfrm>
+          <a:prstGeom prst="rect">
+            <a:avLst/>
+          </a:prstGeom>
+          <a:noFill/>
+        </p:spPr>
+        <p:txBody>
+          <a:bodyPr wrap="square">
+            <a:spAutoFit/>
+          </a:bodyPr>
+          <a:lstStyle/>
+          <a:p>
+            <a:pPr algn="r">
+              <a:defRPr sz="1000" b="0">
+                <a:solidFill>
+                  <a:srgbClr val="AAAAAA"/>
+                </a:solidFill>
+                <a:latin typeface="Palatino Linotype"/>
+              </a:defRPr>
+            </a:pPr>
+            <a:r>
+              <a:t>23</a:t>
             </a:r>
           </a:p>
         </p:txBody>
@@ -9418,6 +9958,42 @@
           </a:graphicData>
         </a:graphic>
       </p:graphicFrame>
+      <p:sp>
+        <p:nvSpPr>
+          <p:cNvPr id="7" name="TextBox 6"/>
+          <p:cNvSpPr txBox="1"/>
+          <p:nvPr/>
+        </p:nvSpPr>
+        <p:spPr>
+          <a:xfrm>
+            <a:off x="11338560" y="6446520"/>
+            <a:ext cx="640080" cy="320040"/>
+          </a:xfrm>
+          <a:prstGeom prst="rect">
+            <a:avLst/>
+          </a:prstGeom>
+          <a:noFill/>
+        </p:spPr>
+        <p:txBody>
+          <a:bodyPr wrap="square">
+            <a:spAutoFit/>
+          </a:bodyPr>
+          <a:lstStyle/>
+          <a:p>
+            <a:pPr algn="r">
+              <a:defRPr sz="1000" b="0">
+                <a:solidFill>
+                  <a:srgbClr val="AAAAAA"/>
+                </a:solidFill>
+                <a:latin typeface="Palatino Linotype"/>
+              </a:defRPr>
+            </a:pPr>
+            <a:r>
+              <a:t>24</a:t>
+            </a:r>
+          </a:p>
+        </p:txBody>
+      </p:sp>
     </p:spTree>
   </p:cSld>
   <p:clrMapOvr>
@@ -9540,6 +10116,42 @@
           </a:p>
         </p:txBody>
       </p:sp>
+      <p:sp>
+        <p:nvSpPr>
+          <p:cNvPr id="5" name="TextBox 4"/>
+          <p:cNvSpPr txBox="1"/>
+          <p:nvPr/>
+        </p:nvSpPr>
+        <p:spPr>
+          <a:xfrm>
+            <a:off x="11338560" y="6446520"/>
+            <a:ext cx="640080" cy="320040"/>
+          </a:xfrm>
+          <a:prstGeom prst="rect">
+            <a:avLst/>
+          </a:prstGeom>
+          <a:noFill/>
+        </p:spPr>
+        <p:txBody>
+          <a:bodyPr wrap="square">
+            <a:spAutoFit/>
+          </a:bodyPr>
+          <a:lstStyle/>
+          <a:p>
+            <a:pPr algn="r">
+              <a:defRPr sz="1000" b="0">
+                <a:solidFill>
+                  <a:srgbClr val="AAAAAA"/>
+                </a:solidFill>
+                <a:latin typeface="Palatino Linotype"/>
+              </a:defRPr>
+            </a:pPr>
+            <a:r>
+              <a:t>25</a:t>
+            </a:r>
+          </a:p>
+        </p:txBody>
+      </p:sp>
     </p:spTree>
   </p:cSld>
   <p:clrMapOvr>
@@ -9662,6 +10274,42 @@
           </a:p>
         </p:txBody>
       </p:sp>
+      <p:sp>
+        <p:nvSpPr>
+          <p:cNvPr id="5" name="TextBox 4"/>
+          <p:cNvSpPr txBox="1"/>
+          <p:nvPr/>
+        </p:nvSpPr>
+        <p:spPr>
+          <a:xfrm>
+            <a:off x="11338560" y="6446520"/>
+            <a:ext cx="640080" cy="320040"/>
+          </a:xfrm>
+          <a:prstGeom prst="rect">
+            <a:avLst/>
+          </a:prstGeom>
+          <a:noFill/>
+        </p:spPr>
+        <p:txBody>
+          <a:bodyPr wrap="square">
+            <a:spAutoFit/>
+          </a:bodyPr>
+          <a:lstStyle/>
+          <a:p>
+            <a:pPr algn="r">
+              <a:defRPr sz="1000" b="0">
+                <a:solidFill>
+                  <a:srgbClr val="AAAAAA"/>
+                </a:solidFill>
+                <a:latin typeface="Palatino Linotype"/>
+              </a:defRPr>
+            </a:pPr>
+            <a:r>
+              <a:t>26</a:t>
+            </a:r>
+          </a:p>
+        </p:txBody>
+      </p:sp>
     </p:spTree>
   </p:cSld>
   <p:clrMapOvr>
@@ -10010,6 +10658,42 @@
           </a:p>
         </p:txBody>
       </p:sp>
+      <p:sp>
+        <p:nvSpPr>
+          <p:cNvPr id="7" name="TextBox 6"/>
+          <p:cNvSpPr txBox="1"/>
+          <p:nvPr/>
+        </p:nvSpPr>
+        <p:spPr>
+          <a:xfrm>
+            <a:off x="11338560" y="6446520"/>
+            <a:ext cx="640080" cy="320040"/>
+          </a:xfrm>
+          <a:prstGeom prst="rect">
+            <a:avLst/>
+          </a:prstGeom>
+          <a:noFill/>
+        </p:spPr>
+        <p:txBody>
+          <a:bodyPr wrap="square">
+            <a:spAutoFit/>
+          </a:bodyPr>
+          <a:lstStyle/>
+          <a:p>
+            <a:pPr algn="r">
+              <a:defRPr sz="1000" b="0">
+                <a:solidFill>
+                  <a:srgbClr val="AAAAAA"/>
+                </a:solidFill>
+                <a:latin typeface="Palatino Linotype"/>
+              </a:defRPr>
+            </a:pPr>
+            <a:r>
+              <a:t>27</a:t>
+            </a:r>
+          </a:p>
+        </p:txBody>
+      </p:sp>
     </p:spTree>
   </p:cSld>
   <p:clrMapOvr>
@@ -10128,6 +10812,42 @@
             </a:pPr>
             <a:r>
               <a:t>Source: Zhong et al., OSDI 2024, Figure 10</a:t>
+            </a:r>
+          </a:p>
+        </p:txBody>
+      </p:sp>
+      <p:sp>
+        <p:nvSpPr>
+          <p:cNvPr id="5" name="TextBox 4"/>
+          <p:cNvSpPr txBox="1"/>
+          <p:nvPr/>
+        </p:nvSpPr>
+        <p:spPr>
+          <a:xfrm>
+            <a:off x="11338560" y="6446520"/>
+            <a:ext cx="640080" cy="320040"/>
+          </a:xfrm>
+          <a:prstGeom prst="rect">
+            <a:avLst/>
+          </a:prstGeom>
+          <a:noFill/>
+        </p:spPr>
+        <p:txBody>
+          <a:bodyPr wrap="square">
+            <a:spAutoFit/>
+          </a:bodyPr>
+          <a:lstStyle/>
+          <a:p>
+            <a:pPr algn="r">
+              <a:defRPr sz="1000" b="0">
+                <a:solidFill>
+                  <a:srgbClr val="AAAAAA"/>
+                </a:solidFill>
+                <a:latin typeface="Palatino Linotype"/>
+              </a:defRPr>
+            </a:pPr>
+            <a:r>
+              <a:t>28</a:t>
             </a:r>
           </a:p>
         </p:txBody>
@@ -10846,6 +11566,42 @@
           </a:p>
         </p:txBody>
       </p:sp>
+      <p:sp>
+        <p:nvSpPr>
+          <p:cNvPr id="5" name="TextBox 4"/>
+          <p:cNvSpPr txBox="1"/>
+          <p:nvPr/>
+        </p:nvSpPr>
+        <p:spPr>
+          <a:xfrm>
+            <a:off x="11338560" y="6446520"/>
+            <a:ext cx="640080" cy="320040"/>
+          </a:xfrm>
+          <a:prstGeom prst="rect">
+            <a:avLst/>
+          </a:prstGeom>
+          <a:noFill/>
+        </p:spPr>
+        <p:txBody>
+          <a:bodyPr wrap="square">
+            <a:spAutoFit/>
+          </a:bodyPr>
+          <a:lstStyle/>
+          <a:p>
+            <a:pPr algn="r">
+              <a:defRPr sz="1000" b="0">
+                <a:solidFill>
+                  <a:srgbClr val="AAAAAA"/>
+                </a:solidFill>
+                <a:latin typeface="Palatino Linotype"/>
+              </a:defRPr>
+            </a:pPr>
+            <a:r>
+              <a:t>29</a:t>
+            </a:r>
+          </a:p>
+        </p:txBody>
+      </p:sp>
     </p:spTree>
   </p:cSld>
   <p:clrMapOvr>
@@ -11357,6 +12113,42 @@
           </a:p>
         </p:txBody>
       </p:sp>
+      <p:sp>
+        <p:nvSpPr>
+          <p:cNvPr id="10" name="TextBox 9"/>
+          <p:cNvSpPr txBox="1"/>
+          <p:nvPr/>
+        </p:nvSpPr>
+        <p:spPr>
+          <a:xfrm>
+            <a:off x="11338560" y="6446520"/>
+            <a:ext cx="640080" cy="320040"/>
+          </a:xfrm>
+          <a:prstGeom prst="rect">
+            <a:avLst/>
+          </a:prstGeom>
+          <a:noFill/>
+        </p:spPr>
+        <p:txBody>
+          <a:bodyPr wrap="square">
+            <a:spAutoFit/>
+          </a:bodyPr>
+          <a:lstStyle/>
+          <a:p>
+            <a:pPr algn="r">
+              <a:defRPr sz="1000" b="0">
+                <a:solidFill>
+                  <a:srgbClr val="AAAAAA"/>
+                </a:solidFill>
+                <a:latin typeface="Palatino Linotype"/>
+              </a:defRPr>
+            </a:pPr>
+            <a:r>
+              <a:t>3</a:t>
+            </a:r>
+          </a:p>
+        </p:txBody>
+      </p:sp>
     </p:spTree>
   </p:cSld>
   <p:clrMapOvr>
@@ -11800,6 +12592,42 @@
           </a:p>
         </p:txBody>
       </p:sp>
+      <p:sp>
+        <p:nvSpPr>
+          <p:cNvPr id="9" name="TextBox 8"/>
+          <p:cNvSpPr txBox="1"/>
+          <p:nvPr/>
+        </p:nvSpPr>
+        <p:spPr>
+          <a:xfrm>
+            <a:off x="11338560" y="6446520"/>
+            <a:ext cx="640080" cy="320040"/>
+          </a:xfrm>
+          <a:prstGeom prst="rect">
+            <a:avLst/>
+          </a:prstGeom>
+          <a:noFill/>
+        </p:spPr>
+        <p:txBody>
+          <a:bodyPr wrap="square">
+            <a:spAutoFit/>
+          </a:bodyPr>
+          <a:lstStyle/>
+          <a:p>
+            <a:pPr algn="r">
+              <a:defRPr sz="1000" b="0">
+                <a:solidFill>
+                  <a:srgbClr val="AAAAAA"/>
+                </a:solidFill>
+                <a:latin typeface="Palatino Linotype"/>
+              </a:defRPr>
+            </a:pPr>
+            <a:r>
+              <a:t>30</a:t>
+            </a:r>
+          </a:p>
+        </p:txBody>
+      </p:sp>
     </p:spTree>
   </p:cSld>
   <p:clrMapOvr>
@@ -12243,6 +13071,42 @@
           </a:p>
         </p:txBody>
       </p:sp>
+      <p:sp>
+        <p:nvSpPr>
+          <p:cNvPr id="9" name="TextBox 8"/>
+          <p:cNvSpPr txBox="1"/>
+          <p:nvPr/>
+        </p:nvSpPr>
+        <p:spPr>
+          <a:xfrm>
+            <a:off x="11338560" y="6446520"/>
+            <a:ext cx="640080" cy="320040"/>
+          </a:xfrm>
+          <a:prstGeom prst="rect">
+            <a:avLst/>
+          </a:prstGeom>
+          <a:noFill/>
+        </p:spPr>
+        <p:txBody>
+          <a:bodyPr wrap="square">
+            <a:spAutoFit/>
+          </a:bodyPr>
+          <a:lstStyle/>
+          <a:p>
+            <a:pPr algn="r">
+              <a:defRPr sz="1000" b="0">
+                <a:solidFill>
+                  <a:srgbClr val="AAAAAA"/>
+                </a:solidFill>
+                <a:latin typeface="Palatino Linotype"/>
+              </a:defRPr>
+            </a:pPr>
+            <a:r>
+              <a:t>31</a:t>
+            </a:r>
+          </a:p>
+        </p:txBody>
+      </p:sp>
     </p:spTree>
   </p:cSld>
   <p:clrMapOvr>
@@ -12569,6 +13433,42 @@
           </a:p>
         </p:txBody>
       </p:sp>
+      <p:sp>
+        <p:nvSpPr>
+          <p:cNvPr id="4" name="TextBox 3"/>
+          <p:cNvSpPr txBox="1"/>
+          <p:nvPr/>
+        </p:nvSpPr>
+        <p:spPr>
+          <a:xfrm>
+            <a:off x="11338560" y="6446520"/>
+            <a:ext cx="640080" cy="320040"/>
+          </a:xfrm>
+          <a:prstGeom prst="rect">
+            <a:avLst/>
+          </a:prstGeom>
+          <a:noFill/>
+        </p:spPr>
+        <p:txBody>
+          <a:bodyPr wrap="square">
+            <a:spAutoFit/>
+          </a:bodyPr>
+          <a:lstStyle/>
+          <a:p>
+            <a:pPr algn="r">
+              <a:defRPr sz="1000" b="0">
+                <a:solidFill>
+                  <a:srgbClr val="AAAAAA"/>
+                </a:solidFill>
+                <a:latin typeface="Palatino Linotype"/>
+              </a:defRPr>
+            </a:pPr>
+            <a:r>
+              <a:t>32</a:t>
+            </a:r>
+          </a:p>
+        </p:txBody>
+      </p:sp>
     </p:spTree>
   </p:cSld>
   <p:clrMapOvr>
@@ -12803,6 +13703,42 @@
             </a:pPr>
             <a:r>
               <a:t>ECE 5545  |  Spring 2026</a:t>
+            </a:r>
+          </a:p>
+        </p:txBody>
+      </p:sp>
+      <p:sp>
+        <p:nvSpPr>
+          <p:cNvPr id="6" name="TextBox 5"/>
+          <p:cNvSpPr txBox="1"/>
+          <p:nvPr/>
+        </p:nvSpPr>
+        <p:spPr>
+          <a:xfrm>
+            <a:off x="11338560" y="6446520"/>
+            <a:ext cx="640080" cy="320040"/>
+          </a:xfrm>
+          <a:prstGeom prst="rect">
+            <a:avLst/>
+          </a:prstGeom>
+          <a:noFill/>
+        </p:spPr>
+        <p:txBody>
+          <a:bodyPr wrap="square">
+            <a:spAutoFit/>
+          </a:bodyPr>
+          <a:lstStyle/>
+          <a:p>
+            <a:pPr algn="r">
+              <a:defRPr sz="1000" b="0">
+                <a:solidFill>
+                  <a:srgbClr val="556688"/>
+                </a:solidFill>
+                <a:latin typeface="Palatino Linotype"/>
+              </a:defRPr>
+            </a:pPr>
+            <a:r>
+              <a:t>33</a:t>
             </a:r>
           </a:p>
         </p:txBody>
@@ -13521,6 +14457,42 @@
           </a:p>
         </p:txBody>
       </p:sp>
+      <p:sp>
+        <p:nvSpPr>
+          <p:cNvPr id="5" name="TextBox 4"/>
+          <p:cNvSpPr txBox="1"/>
+          <p:nvPr/>
+        </p:nvSpPr>
+        <p:spPr>
+          <a:xfrm>
+            <a:off x="11338560" y="6446520"/>
+            <a:ext cx="640080" cy="320040"/>
+          </a:xfrm>
+          <a:prstGeom prst="rect">
+            <a:avLst/>
+          </a:prstGeom>
+          <a:noFill/>
+        </p:spPr>
+        <p:txBody>
+          <a:bodyPr wrap="square">
+            <a:spAutoFit/>
+          </a:bodyPr>
+          <a:lstStyle/>
+          <a:p>
+            <a:pPr algn="r">
+              <a:defRPr sz="1000" b="0">
+                <a:solidFill>
+                  <a:srgbClr val="AAAAAA"/>
+                </a:solidFill>
+                <a:latin typeface="Palatino Linotype"/>
+              </a:defRPr>
+            </a:pPr>
+            <a:r>
+              <a:t>4</a:t>
+            </a:r>
+          </a:p>
+        </p:txBody>
+      </p:sp>
     </p:spTree>
   </p:cSld>
   <p:clrMapOvr>
@@ -14207,6 +15179,42 @@
           </a:p>
         </p:txBody>
       </p:sp>
+      <p:sp>
+        <p:nvSpPr>
+          <p:cNvPr id="6" name="TextBox 5"/>
+          <p:cNvSpPr txBox="1"/>
+          <p:nvPr/>
+        </p:nvSpPr>
+        <p:spPr>
+          <a:xfrm>
+            <a:off x="11338560" y="6446520"/>
+            <a:ext cx="640080" cy="320040"/>
+          </a:xfrm>
+          <a:prstGeom prst="rect">
+            <a:avLst/>
+          </a:prstGeom>
+          <a:noFill/>
+        </p:spPr>
+        <p:txBody>
+          <a:bodyPr wrap="square">
+            <a:spAutoFit/>
+          </a:bodyPr>
+          <a:lstStyle/>
+          <a:p>
+            <a:pPr algn="r">
+              <a:defRPr sz="1000" b="0">
+                <a:solidFill>
+                  <a:srgbClr val="AAAAAA"/>
+                </a:solidFill>
+                <a:latin typeface="Palatino Linotype"/>
+              </a:defRPr>
+            </a:pPr>
+            <a:r>
+              <a:t>5</a:t>
+            </a:r>
+          </a:p>
+        </p:txBody>
+      </p:sp>
     </p:spTree>
   </p:cSld>
   <p:clrMapOvr>
@@ -14777,6 +15785,42 @@
           </a:p>
         </p:txBody>
       </p:sp>
+      <p:sp>
+        <p:nvSpPr>
+          <p:cNvPr id="11" name="TextBox 10"/>
+          <p:cNvSpPr txBox="1"/>
+          <p:nvPr/>
+        </p:nvSpPr>
+        <p:spPr>
+          <a:xfrm>
+            <a:off x="11338560" y="6446520"/>
+            <a:ext cx="640080" cy="320040"/>
+          </a:xfrm>
+          <a:prstGeom prst="rect">
+            <a:avLst/>
+          </a:prstGeom>
+          <a:noFill/>
+        </p:spPr>
+        <p:txBody>
+          <a:bodyPr wrap="square">
+            <a:spAutoFit/>
+          </a:bodyPr>
+          <a:lstStyle/>
+          <a:p>
+            <a:pPr algn="r">
+              <a:defRPr sz="1000" b="0">
+                <a:solidFill>
+                  <a:srgbClr val="AAAAAA"/>
+                </a:solidFill>
+                <a:latin typeface="Palatino Linotype"/>
+              </a:defRPr>
+            </a:pPr>
+            <a:r>
+              <a:t>6</a:t>
+            </a:r>
+          </a:p>
+        </p:txBody>
+      </p:sp>
     </p:spTree>
   </p:cSld>
   <p:clrMapOvr>
@@ -14899,6 +15943,42 @@
           </a:p>
         </p:txBody>
       </p:sp>
+      <p:sp>
+        <p:nvSpPr>
+          <p:cNvPr id="5" name="TextBox 4"/>
+          <p:cNvSpPr txBox="1"/>
+          <p:nvPr/>
+        </p:nvSpPr>
+        <p:spPr>
+          <a:xfrm>
+            <a:off x="11338560" y="6446520"/>
+            <a:ext cx="640080" cy="320040"/>
+          </a:xfrm>
+          <a:prstGeom prst="rect">
+            <a:avLst/>
+          </a:prstGeom>
+          <a:noFill/>
+        </p:spPr>
+        <p:txBody>
+          <a:bodyPr wrap="square">
+            <a:spAutoFit/>
+          </a:bodyPr>
+          <a:lstStyle/>
+          <a:p>
+            <a:pPr algn="r">
+              <a:defRPr sz="1000" b="0">
+                <a:solidFill>
+                  <a:srgbClr val="AAAAAA"/>
+                </a:solidFill>
+                <a:latin typeface="Palatino Linotype"/>
+              </a:defRPr>
+            </a:pPr>
+            <a:r>
+              <a:t>7</a:t>
+            </a:r>
+          </a:p>
+        </p:txBody>
+      </p:sp>
     </p:spTree>
   </p:cSld>
   <p:clrMapOvr>
@@ -15056,6 +16136,42 @@
           </a:p>
         </p:txBody>
       </p:sp>
+      <p:sp>
+        <p:nvSpPr>
+          <p:cNvPr id="5" name="TextBox 4"/>
+          <p:cNvSpPr txBox="1"/>
+          <p:nvPr/>
+        </p:nvSpPr>
+        <p:spPr>
+          <a:xfrm>
+            <a:off x="11338560" y="6446520"/>
+            <a:ext cx="640080" cy="320040"/>
+          </a:xfrm>
+          <a:prstGeom prst="rect">
+            <a:avLst/>
+          </a:prstGeom>
+          <a:noFill/>
+        </p:spPr>
+        <p:txBody>
+          <a:bodyPr wrap="square">
+            <a:spAutoFit/>
+          </a:bodyPr>
+          <a:lstStyle/>
+          <a:p>
+            <a:pPr algn="r">
+              <a:defRPr sz="1000" b="0">
+                <a:solidFill>
+                  <a:srgbClr val="556688"/>
+                </a:solidFill>
+                <a:latin typeface="Palatino Linotype"/>
+              </a:defRPr>
+            </a:pPr>
+            <a:r>
+              <a:t>8</a:t>
+            </a:r>
+          </a:p>
+        </p:txBody>
+      </p:sp>
     </p:spTree>
   </p:cSld>
   <p:clrMapOvr>
@@ -15694,6 +16810,42 @@
             </a:pPr>
             <a:r>
               <a:t>Splitwise Figure 3-4, Table IV</a:t>
+            </a:r>
+          </a:p>
+        </p:txBody>
+      </p:sp>
+      <p:sp>
+        <p:nvSpPr>
+          <p:cNvPr id="13" name="TextBox 12"/>
+          <p:cNvSpPr txBox="1"/>
+          <p:nvPr/>
+        </p:nvSpPr>
+        <p:spPr>
+          <a:xfrm>
+            <a:off x="11338560" y="6446520"/>
+            <a:ext cx="640080" cy="320040"/>
+          </a:xfrm>
+          <a:prstGeom prst="rect">
+            <a:avLst/>
+          </a:prstGeom>
+          <a:noFill/>
+        </p:spPr>
+        <p:txBody>
+          <a:bodyPr wrap="square">
+            <a:spAutoFit/>
+          </a:bodyPr>
+          <a:lstStyle/>
+          <a:p>
+            <a:pPr algn="r">
+              <a:defRPr sz="1000" b="0">
+                <a:solidFill>
+                  <a:srgbClr val="AAAAAA"/>
+                </a:solidFill>
+                <a:latin typeface="Palatino Linotype"/>
+              </a:defRPr>
+            </a:pPr>
+            <a:r>
+              <a:t>9</a:t>
             </a:r>
           </a:p>
         </p:txBody>

</xml_diff>